<commit_message>
Update presentation to match original design while fixing issues
Update presentation metadata to reflect that original design elements were preserved while addressing specific issues in the deck.

Replit-Commit-Author: Agent
Replit-Commit-Session-Id: 85f09f3c-352d-446d-b98e-3f307c26fc5a
Replit-Commit-Checkpoint-Type: full_checkpoint
Replit-Commit-Event-Id: 4531e310-47c5-4f36-a9a0-a15da80c30e8
Replit-Commit-Screenshot-Url: https://storage.googleapis.com/screenshot-production-us-central1/3bd53afc-ff4f-401b-9e3d-b367791ef629/85f09f3c-352d-446d-b98e-3f307c26fc5a/yZH2El0
Replit-Helium-Checkpoint-Created: true
</commit_message>
<xml_diff>
--- a/attached_assets/VaughnMartin-Investor-Deck-v11-fixed.pptx
+++ b/attached_assets/VaughnMartin-Investor-Deck-v11-fixed.pptx
@@ -3874,7 +3874,7 @@
             <a:avLst/>
           </a:prstGeom>
           <a:solidFill>
-            <a:srgbClr val="0A0F2E"/>
+            <a:srgbClr val="F8F7F4"/>
           </a:solidFill>
           <a:ln>
             <a:noFill/>
@@ -11653,7 +11653,7 @@
             <a:avLst/>
           </a:prstGeom>
           <a:solidFill>
-            <a:srgbClr val="0A0F2E"/>
+            <a:srgbClr val="F8F7F4"/>
           </a:solidFill>
           <a:ln>
             <a:noFill/>
@@ -14672,7 +14672,7 @@
             <a:avLst/>
           </a:prstGeom>
           <a:solidFill>
-            <a:srgbClr val="0A0F2E"/>
+            <a:srgbClr val="F8F7F4"/>
           </a:solidFill>
           <a:ln>
             <a:noFill/>

</xml_diff>